<commit_message>
Update Testsúlycsökkentő gyógyszeres terápiák.pptx
</commit_message>
<xml_diff>
--- a/Testsúlycsökkentő gyógyszeres terápiák.pptx
+++ b/Testsúlycsökkentő gyógyszeres terápiák.pptx
@@ -7,10 +7,11 @@
   <p:sldIdLst>
     <p:sldId id="256" r:id="rId2"/>
     <p:sldId id="257" r:id="rId3"/>
-    <p:sldId id="259" r:id="rId4"/>
-    <p:sldId id="260" r:id="rId5"/>
-    <p:sldId id="258" r:id="rId6"/>
-    <p:sldId id="261" r:id="rId7"/>
+    <p:sldId id="262" r:id="rId4"/>
+    <p:sldId id="259" r:id="rId5"/>
+    <p:sldId id="260" r:id="rId6"/>
+    <p:sldId id="258" r:id="rId7"/>
+    <p:sldId id="261" r:id="rId8"/>
   </p:sldIdLst>
   <p:sldSz cx="12192000" cy="6858000"/>
   <p:notesSz cx="6858000" cy="9144000"/>
@@ -109,6 +110,11 @@
       </a:defRPr>
     </a:lvl9pPr>
   </p:defaultTextStyle>
+  <p:extLst>
+    <p:ext uri="{EFAFB233-063F-42B5-8137-9DF3F51BA10A}">
+      <p15:sldGuideLst xmlns:p15="http://schemas.microsoft.com/office/powerpoint/2012/main"/>
+    </p:ext>
+  </p:extLst>
 </p:presentation>
 </file>
 
@@ -260,7 +266,7 @@
           <a:lstStyle/>
           <a:p>
             <a:fld id="{8C9917DF-FD8E-5A4B-A429-071A0169D668}" type="datetimeFigureOut">
-              <a:t>2026. 04. 16.</a:t>
+              <a:t>2026. 04. 23.</a:t>
             </a:fld>
             <a:endParaRPr lang="en-HU"/>
           </a:p>
@@ -458,7 +464,7 @@
           <a:lstStyle/>
           <a:p>
             <a:fld id="{8C9917DF-FD8E-5A4B-A429-071A0169D668}" type="datetimeFigureOut">
-              <a:t>2026. 04. 16.</a:t>
+              <a:t>2026. 04. 23.</a:t>
             </a:fld>
             <a:endParaRPr lang="en-HU"/>
           </a:p>
@@ -666,7 +672,7 @@
           <a:lstStyle/>
           <a:p>
             <a:fld id="{8C9917DF-FD8E-5A4B-A429-071A0169D668}" type="datetimeFigureOut">
-              <a:t>2026. 04. 16.</a:t>
+              <a:t>2026. 04. 23.</a:t>
             </a:fld>
             <a:endParaRPr lang="en-HU"/>
           </a:p>
@@ -864,7 +870,7 @@
           <a:lstStyle/>
           <a:p>
             <a:fld id="{8C9917DF-FD8E-5A4B-A429-071A0169D668}" type="datetimeFigureOut">
-              <a:t>2026. 04. 16.</a:t>
+              <a:t>2026. 04. 23.</a:t>
             </a:fld>
             <a:endParaRPr lang="en-HU"/>
           </a:p>
@@ -1138,7 +1144,7 @@
           <a:lstStyle/>
           <a:p>
             <a:fld id="{8C9917DF-FD8E-5A4B-A429-071A0169D668}" type="datetimeFigureOut">
-              <a:t>2026. 04. 16.</a:t>
+              <a:t>2026. 04. 23.</a:t>
             </a:fld>
             <a:endParaRPr lang="en-HU"/>
           </a:p>
@@ -1404,7 +1410,7 @@
           <a:lstStyle/>
           <a:p>
             <a:fld id="{8C9917DF-FD8E-5A4B-A429-071A0169D668}" type="datetimeFigureOut">
-              <a:t>2026. 04. 16.</a:t>
+              <a:t>2026. 04. 23.</a:t>
             </a:fld>
             <a:endParaRPr lang="en-HU"/>
           </a:p>
@@ -1817,7 +1823,7 @@
           <a:lstStyle/>
           <a:p>
             <a:fld id="{8C9917DF-FD8E-5A4B-A429-071A0169D668}" type="datetimeFigureOut">
-              <a:t>2026. 04. 16.</a:t>
+              <a:t>2026. 04. 23.</a:t>
             </a:fld>
             <a:endParaRPr lang="en-HU"/>
           </a:p>
@@ -1957,7 +1963,7 @@
           <a:lstStyle/>
           <a:p>
             <a:fld id="{8C9917DF-FD8E-5A4B-A429-071A0169D668}" type="datetimeFigureOut">
-              <a:t>2026. 04. 16.</a:t>
+              <a:t>2026. 04. 23.</a:t>
             </a:fld>
             <a:endParaRPr lang="en-HU"/>
           </a:p>
@@ -2068,7 +2074,7 @@
           <a:lstStyle/>
           <a:p>
             <a:fld id="{8C9917DF-FD8E-5A4B-A429-071A0169D668}" type="datetimeFigureOut">
-              <a:t>2026. 04. 16.</a:t>
+              <a:t>2026. 04. 23.</a:t>
             </a:fld>
             <a:endParaRPr lang="en-HU"/>
           </a:p>
@@ -2379,7 +2385,7 @@
           <a:lstStyle/>
           <a:p>
             <a:fld id="{8C9917DF-FD8E-5A4B-A429-071A0169D668}" type="datetimeFigureOut">
-              <a:t>2026. 04. 16.</a:t>
+              <a:t>2026. 04. 23.</a:t>
             </a:fld>
             <a:endParaRPr lang="en-HU"/>
           </a:p>
@@ -2666,7 +2672,7 @@
           <a:lstStyle/>
           <a:p>
             <a:fld id="{8C9917DF-FD8E-5A4B-A429-071A0169D668}" type="datetimeFigureOut">
-              <a:t>2026. 04. 16.</a:t>
+              <a:t>2026. 04. 23.</a:t>
             </a:fld>
             <a:endParaRPr lang="en-HU"/>
           </a:p>
@@ -2907,7 +2913,7 @@
           </a:lstStyle>
           <a:p>
             <a:fld id="{8C9917DF-FD8E-5A4B-A429-071A0169D668}" type="datetimeFigureOut">
-              <a:t>2026. 04. 16.</a:t>
+              <a:t>2026. 04. 23.</a:t>
             </a:fld>
             <a:endParaRPr lang="en-HU"/>
           </a:p>
@@ -3523,7 +3529,7 @@
           <p:cNvPr id="2" name="Title 1">
             <a:extLst>
               <a:ext uri="{FF2B5EF4-FFF2-40B4-BE49-F238E27FC236}">
-                <a16:creationId xmlns:a16="http://schemas.microsoft.com/office/drawing/2014/main" id="{5172F720-8A5B-06E0-4FF0-415FF29DEB31}"/>
+                <a16:creationId xmlns:a16="http://schemas.microsoft.com/office/drawing/2014/main" id="{9101AFE8-ABD4-BCF2-2F0B-4DDCAAA59397}"/>
               </a:ext>
             </a:extLst>
           </p:cNvPr>
@@ -3540,10 +3546,9 @@
           <a:lstStyle/>
           <a:p>
             <a:r>
-              <a:rPr lang="hu-HU" b="1"/>
-              <a:t>Gyakoribb mellékhatások</a:t>
-            </a:r>
-            <a:endParaRPr lang="en-HU"/>
+              <a:rPr lang="en-HU" b="1"/>
+              <a:t>Ellenjavallatok</a:t>
+            </a:r>
           </a:p>
         </p:txBody>
       </p:sp>
@@ -3552,7 +3557,7 @@
           <p:cNvPr id="3" name="Content Placeholder 2">
             <a:extLst>
               <a:ext uri="{FF2B5EF4-FFF2-40B4-BE49-F238E27FC236}">
-                <a16:creationId xmlns:a16="http://schemas.microsoft.com/office/drawing/2014/main" id="{FC7E3A50-1EEF-607B-03C3-56B25C18547A}"/>
+                <a16:creationId xmlns:a16="http://schemas.microsoft.com/office/drawing/2014/main" id="{4022614A-23D0-B275-4015-739224BB73AA}"/>
               </a:ext>
             </a:extLst>
           </p:cNvPr>
@@ -3569,66 +3574,6 @@
             <a:normAutofit lnSpcReduction="10000"/>
           </a:bodyPr>
           <a:lstStyle/>
-          <a:p>
-            <a:pPr marL="0" indent="0">
-              <a:buNone/>
-            </a:pPr>
-            <a:r>
-              <a:rPr lang="en-HU"/>
-              <a:t>Hányinger, hányás</a:t>
-            </a:r>
-          </a:p>
-          <a:p>
-            <a:pPr marL="0" indent="0">
-              <a:buNone/>
-            </a:pPr>
-            <a:r>
-              <a:rPr lang="en-HU"/>
-              <a:t>Hasmenés vagy székrekedés</a:t>
-            </a:r>
-          </a:p>
-          <a:p>
-            <a:pPr marL="0" indent="0">
-              <a:buNone/>
-            </a:pPr>
-            <a:r>
-              <a:rPr lang="en-HU"/>
-              <a:t>Puffadás vagy teltségérzés</a:t>
-            </a:r>
-          </a:p>
-          <a:p>
-            <a:pPr marL="0" indent="0">
-              <a:buNone/>
-            </a:pPr>
-            <a:r>
-              <a:rPr lang="en-HU"/>
-              <a:t>Fáradtság</a:t>
-            </a:r>
-          </a:p>
-          <a:p>
-            <a:pPr marL="0" indent="0">
-              <a:buNone/>
-            </a:pPr>
-            <a:r>
-              <a:rPr lang="en-HU"/>
-              <a:t>Hajhullás</a:t>
-            </a:r>
-          </a:p>
-          <a:p>
-            <a:pPr marL="0" indent="0">
-              <a:buNone/>
-            </a:pPr>
-            <a:endParaRPr lang="en-HU"/>
-          </a:p>
-          <a:p>
-            <a:pPr marL="0" indent="0">
-              <a:buNone/>
-            </a:pPr>
-            <a:r>
-              <a:rPr lang="en-HU" b="1"/>
-              <a:t>Ritka, de fontos kockázatok</a:t>
-            </a:r>
-          </a:p>
           <a:p>
             <a:pPr>
               <a:buFontTx/>
@@ -3636,7 +3581,7 @@
             </a:pPr>
             <a:r>
               <a:rPr lang="en-HU"/>
-              <a:t>hasnyálmirigy gyulladás – erős, övszerű hasi fájdalom hányással</a:t>
+              <a:t>terhesség, szoptatás</a:t>
             </a:r>
           </a:p>
           <a:p>
@@ -3646,15 +3591,76 @@
             </a:pPr>
             <a:r>
               <a:rPr lang="en-HU"/>
+              <a:t>bizonyos típusú pajzsmirigyrákok</a:t>
+            </a:r>
+          </a:p>
+          <a:p>
+            <a:pPr>
+              <a:buFontTx/>
+              <a:buChar char="-"/>
+            </a:pPr>
+            <a:r>
+              <a:rPr lang="en-HU"/>
+              <a:t>ún. MEN-2 szindróma (öröklődő pajzsmirigy + mellékvese daganat)</a:t>
+            </a:r>
+          </a:p>
+          <a:p>
+            <a:pPr>
+              <a:buFontTx/>
+              <a:buChar char="-"/>
+            </a:pPr>
+            <a:r>
+              <a:rPr lang="en-HU"/>
+              <a:t>bizonyos típusú hasnyálmirigy gyulladás az előzményben</a:t>
+            </a:r>
+          </a:p>
+          <a:p>
+            <a:pPr marL="0" indent="0">
+              <a:buNone/>
+            </a:pPr>
+            <a:endParaRPr lang="en-HU" b="1"/>
+          </a:p>
+          <a:p>
+            <a:pPr marL="0" indent="0">
+              <a:buNone/>
+            </a:pPr>
+            <a:r>
+              <a:rPr lang="en-HU" b="1"/>
+              <a:t>Ritka, de fontos kezelés alatti kockázatok</a:t>
+            </a:r>
+          </a:p>
+          <a:p>
+            <a:pPr>
+              <a:buFontTx/>
+              <a:buChar char="-"/>
+            </a:pPr>
+            <a:r>
+              <a:rPr lang="en-HU"/>
+              <a:t>hasnyálmirigy gyulladás – erős, övszerű hasi fájdalom hányással</a:t>
+            </a:r>
+          </a:p>
+          <a:p>
+            <a:pPr>
+              <a:buFontTx/>
+              <a:buChar char="-"/>
+            </a:pPr>
+            <a:r>
+              <a:rPr lang="en-HU"/>
               <a:t>egyoldali fájdalmatlan látásvesztés</a:t>
             </a:r>
+          </a:p>
+          <a:p>
+            <a:pPr marL="0" indent="0">
+              <a:buNone/>
+            </a:pPr>
+            <a:endParaRPr lang="en-HU"/>
           </a:p>
         </p:txBody>
       </p:sp>
     </p:spTree>
     <p:extLst>
       <p:ext uri="{BB962C8B-B14F-4D97-AF65-F5344CB8AC3E}">
-        <p14:creationId xmlns:p14="http://schemas.microsoft.com/office/powerpoint/2010/main" val="1797897794"/>
+        <p14:creationId xmlns:p14="http://schemas.microsoft.com/office/powerpoint/2010/main" val="1405731578"/>
       </p:ext>
     </p:extLst>
   </p:cSld>
@@ -3686,7 +3692,7 @@
           <p:cNvPr id="2" name="Title 1">
             <a:extLst>
               <a:ext uri="{FF2B5EF4-FFF2-40B4-BE49-F238E27FC236}">
-                <a16:creationId xmlns:a16="http://schemas.microsoft.com/office/drawing/2014/main" id="{CAE58BA9-93C5-3F91-FA1C-6F665CC15BCF}"/>
+                <a16:creationId xmlns:a16="http://schemas.microsoft.com/office/drawing/2014/main" id="{5172F720-8A5B-06E0-4FF0-415FF29DEB31}"/>
               </a:ext>
             </a:extLst>
           </p:cNvPr>
@@ -3703,9 +3709,10 @@
           <a:lstStyle/>
           <a:p>
             <a:r>
-              <a:rPr lang="en-HU" b="1"/>
-              <a:t>Mire kell figyelni?</a:t>
-            </a:r>
+              <a:rPr lang="hu-HU" b="1"/>
+              <a:t>Gyakoribb mellékhatások</a:t>
+            </a:r>
+            <a:endParaRPr lang="en-HU"/>
           </a:p>
         </p:txBody>
       </p:sp>
@@ -3714,7 +3721,7 @@
           <p:cNvPr id="3" name="Content Placeholder 2">
             <a:extLst>
               <a:ext uri="{FF2B5EF4-FFF2-40B4-BE49-F238E27FC236}">
-                <a16:creationId xmlns:a16="http://schemas.microsoft.com/office/drawing/2014/main" id="{49DC2C35-5DC2-1029-B05F-4150FF524E45}"/>
+                <a16:creationId xmlns:a16="http://schemas.microsoft.com/office/drawing/2014/main" id="{FC7E3A50-1EEF-607B-03C3-56B25C18547A}"/>
               </a:ext>
             </a:extLst>
           </p:cNvPr>
@@ -3728,71 +3735,58 @@
         <p:spPr/>
         <p:txBody>
           <a:bodyPr>
-            <a:normAutofit fontScale="92500" lnSpcReduction="10000"/>
+            <a:normAutofit/>
           </a:bodyPr>
           <a:lstStyle/>
           <a:p>
+            <a:pPr marL="0" indent="0">
+              <a:buNone/>
+            </a:pPr>
+            <a:endParaRPr lang="en-HU"/>
+          </a:p>
+          <a:p>
+            <a:pPr marL="0" indent="0">
+              <a:buNone/>
+            </a:pPr>
             <a:r>
               <a:rPr lang="en-HU"/>
-              <a:t>nagy volumenű étkezés, alkoholfogyasztás ne legyen</a:t>
-            </a:r>
-          </a:p>
-          <a:p>
+              <a:t>Hányinger, hányás</a:t>
+            </a:r>
+          </a:p>
+          <a:p>
+            <a:pPr marL="0" indent="0">
+              <a:buNone/>
+            </a:pPr>
             <a:r>
               <a:rPr lang="en-HU"/>
-              <a:t>megfelelő folyadékfogyasztásra figyeljen</a:t>
-            </a:r>
-          </a:p>
-          <a:p>
-            <a:endParaRPr lang="en-HU"/>
-          </a:p>
-          <a:p>
+              <a:t>Hasmenés vagy székrekedés</a:t>
+            </a:r>
+          </a:p>
+          <a:p>
+            <a:pPr marL="0" indent="0">
+              <a:buNone/>
+            </a:pPr>
             <a:r>
               <a:rPr lang="en-HU"/>
-              <a:t>életmód, tréning, fehérjebevitel ugyanúgy fontos az izomvesztés elkerülésére</a:t>
-            </a:r>
-          </a:p>
-          <a:p>
-            <a:endParaRPr lang="en-HU"/>
+              <a:t>Puffadás vagy teltségérzés</a:t>
+            </a:r>
           </a:p>
           <a:p>
             <a:pPr marL="0" indent="0">
               <a:buNone/>
             </a:pPr>
             <a:r>
-              <a:rPr lang="en-HU" sz="3000" b="1"/>
-              <a:t>ELLENJAVALLATOK</a:t>
-            </a:r>
-            <a:endParaRPr lang="en-HU" b="1"/>
-          </a:p>
-          <a:p>
-            <a:pPr>
-              <a:buFontTx/>
-              <a:buChar char="-"/>
+              <a:rPr lang="en-HU"/>
+              <a:t>Fáradtság</a:t>
+            </a:r>
+          </a:p>
+          <a:p>
+            <a:pPr marL="0" indent="0">
+              <a:buNone/>
             </a:pPr>
             <a:r>
               <a:rPr lang="en-HU"/>
-              <a:t>terhesség, szoptatás</a:t>
-            </a:r>
-          </a:p>
-          <a:p>
-            <a:pPr>
-              <a:buFontTx/>
-              <a:buChar char="-"/>
-            </a:pPr>
-            <a:r>
-              <a:rPr lang="en-HU"/>
-              <a:t>bizonyos típusú pajzsmirigyrákok, ún. MEN-2 szindróma</a:t>
-            </a:r>
-          </a:p>
-          <a:p>
-            <a:pPr>
-              <a:buFontTx/>
-              <a:buChar char="-"/>
-            </a:pPr>
-            <a:r>
-              <a:rPr lang="en-HU"/>
-              <a:t>bizonyos típusú hasnyálmirigy gyulladás az előzményben</a:t>
+              <a:t>Hajhullás</a:t>
             </a:r>
           </a:p>
         </p:txBody>
@@ -3800,7 +3794,7 @@
     </p:spTree>
     <p:extLst>
       <p:ext uri="{BB962C8B-B14F-4D97-AF65-F5344CB8AC3E}">
-        <p14:creationId xmlns:p14="http://schemas.microsoft.com/office/powerpoint/2010/main" val="3775309155"/>
+        <p14:creationId xmlns:p14="http://schemas.microsoft.com/office/powerpoint/2010/main" val="1797897794"/>
       </p:ext>
     </p:extLst>
   </p:cSld>
@@ -3832,6 +3826,115 @@
           <p:cNvPr id="2" name="Title 1">
             <a:extLst>
               <a:ext uri="{FF2B5EF4-FFF2-40B4-BE49-F238E27FC236}">
+                <a16:creationId xmlns:a16="http://schemas.microsoft.com/office/drawing/2014/main" id="{CAE58BA9-93C5-3F91-FA1C-6F665CC15BCF}"/>
+              </a:ext>
+            </a:extLst>
+          </p:cNvPr>
+          <p:cNvSpPr>
+            <a:spLocks noGrp="1"/>
+          </p:cNvSpPr>
+          <p:nvPr>
+            <p:ph type="title"/>
+          </p:nvPr>
+        </p:nvSpPr>
+        <p:spPr/>
+        <p:txBody>
+          <a:bodyPr/>
+          <a:lstStyle/>
+          <a:p>
+            <a:r>
+              <a:rPr lang="en-HU" b="1"/>
+              <a:t>Mire kell figyelni?</a:t>
+            </a:r>
+          </a:p>
+        </p:txBody>
+      </p:sp>
+      <p:sp>
+        <p:nvSpPr>
+          <p:cNvPr id="3" name="Content Placeholder 2">
+            <a:extLst>
+              <a:ext uri="{FF2B5EF4-FFF2-40B4-BE49-F238E27FC236}">
+                <a16:creationId xmlns:a16="http://schemas.microsoft.com/office/drawing/2014/main" id="{49DC2C35-5DC2-1029-B05F-4150FF524E45}"/>
+              </a:ext>
+            </a:extLst>
+          </p:cNvPr>
+          <p:cNvSpPr>
+            <a:spLocks noGrp="1"/>
+          </p:cNvSpPr>
+          <p:nvPr>
+            <p:ph idx="1"/>
+          </p:nvPr>
+        </p:nvSpPr>
+        <p:spPr/>
+        <p:txBody>
+          <a:bodyPr>
+            <a:normAutofit/>
+          </a:bodyPr>
+          <a:lstStyle/>
+          <a:p>
+            <a:endParaRPr lang="en-HU"/>
+          </a:p>
+          <a:p>
+            <a:endParaRPr lang="en-HU"/>
+          </a:p>
+          <a:p>
+            <a:r>
+              <a:rPr lang="en-HU"/>
+              <a:t>nagy volumenű étkezés, alkoholfogyasztás ne legyen</a:t>
+            </a:r>
+          </a:p>
+          <a:p>
+            <a:r>
+              <a:rPr lang="en-HU"/>
+              <a:t>megfelelő folyadékfogyasztásra figyeljen</a:t>
+            </a:r>
+          </a:p>
+          <a:p>
+            <a:endParaRPr lang="en-HU"/>
+          </a:p>
+          <a:p>
+            <a:r>
+              <a:rPr lang="en-HU"/>
+              <a:t>életmód, tréning, fehérjebevitel ugyanúgy fontos az izomvesztés elkerülésére</a:t>
+            </a:r>
+          </a:p>
+        </p:txBody>
+      </p:sp>
+    </p:spTree>
+    <p:extLst>
+      <p:ext uri="{BB962C8B-B14F-4D97-AF65-F5344CB8AC3E}">
+        <p14:creationId xmlns:p14="http://schemas.microsoft.com/office/powerpoint/2010/main" val="3775309155"/>
+      </p:ext>
+    </p:extLst>
+  </p:cSld>
+  <p:clrMapOvr>
+    <a:masterClrMapping/>
+  </p:clrMapOvr>
+</p:sld>
+</file>
+
+<file path=ppt/slides/slide6.xml><?xml version="1.0" encoding="utf-8"?>
+<p:sld xmlns:a="http://schemas.openxmlformats.org/drawingml/2006/main" xmlns:r="http://schemas.openxmlformats.org/officeDocument/2006/relationships" xmlns:p="http://schemas.openxmlformats.org/presentationml/2006/main">
+  <p:cSld>
+    <p:spTree>
+      <p:nvGrpSpPr>
+        <p:cNvPr id="1" name=""/>
+        <p:cNvGrpSpPr/>
+        <p:nvPr/>
+      </p:nvGrpSpPr>
+      <p:grpSpPr>
+        <a:xfrm>
+          <a:off x="0" y="0"/>
+          <a:ext cx="0" cy="0"/>
+          <a:chOff x="0" y="0"/>
+          <a:chExt cx="0" cy="0"/>
+        </a:xfrm>
+      </p:grpSpPr>
+      <p:sp>
+        <p:nvSpPr>
+          <p:cNvPr id="2" name="Title 1">
+            <a:extLst>
+              <a:ext uri="{FF2B5EF4-FFF2-40B4-BE49-F238E27FC236}">
                 <a16:creationId xmlns:a16="http://schemas.microsoft.com/office/drawing/2014/main" id="{614B8E35-8980-EF83-8097-942C62E8B60B}"/>
               </a:ext>
             </a:extLst>
@@ -3947,7 +4050,7 @@
 </p:sld>
 </file>
 
-<file path=ppt/slides/slide6.xml><?xml version="1.0" encoding="utf-8"?>
+<file path=ppt/slides/slide7.xml><?xml version="1.0" encoding="utf-8"?>
 <p:sld xmlns:a="http://schemas.openxmlformats.org/drawingml/2006/main" xmlns:r="http://schemas.openxmlformats.org/officeDocument/2006/relationships" xmlns:p="http://schemas.openxmlformats.org/presentationml/2006/main">
   <p:cSld>
     <p:spTree>

</xml_diff>